<commit_message>
Deploying to gh-pages from @ tamanh-oxford/capacity-development@94174db61c2d038fb5060eeddacaf5309e90733b 🚀
</commit_message>
<xml_diff>
--- a/data-frameworks/04-un-tech.pptx
+++ b/data-frameworks/04-un-tech.pptx
@@ -15,6 +15,9 @@
     <p:sldId id="263" r:id="rId9"/>
     <p:sldId id="264" r:id="rId10"/>
     <p:sldId id="265" r:id="rId11"/>
+    <p:sldId id="266" r:id="rId12"/>
+    <p:sldId id="267" r:id="rId13"/>
+    <p:sldId id="268" r:id="rId14"/>
   </p:sldIdLst>
   <p:sldSz cx="9144000" cy="5143500" type="screen16x9"/>
   <p:notesSz cx="6858000" cy="9144000"/>
@@ -3203,6 +3206,160 @@
             </a:pPr>
             <a:r>
               <a:rPr/>
+              <a:t>The problem (continued)</a:t>
+            </a:r>
+          </a:p>
+        </p:txBody>
+      </p:sp>
+      <p:sp>
+        <p:nvSpPr>
+          <p:cNvPr id="3" name="Content Placeholder 2"/>
+          <p:cNvSpPr>
+            <a:spLocks noGrp="1"/>
+          </p:cNvSpPr>
+          <p:nvPr>
+            <p:ph idx="1"/>
+          </p:nvPr>
+        </p:nvSpPr>
+        <p:spPr/>
+        <p:txBody>
+          <a:bodyPr/>
+          <a:lstStyle/>
+          <a:p>
+            <a:pPr lvl="0"/>
+            <a:r>
+              <a:rPr/>
+              <a:t>Without interoperability, data cannot be shared effectively across entities, leading to blind spots, wasted effort, and missed opportunities to address interconnected global challenges.</a:t>
+            </a:r>
+          </a:p>
+          <a:p>
+            <a:pPr lvl="0"/>
+            <a:r>
+              <a:rPr/>
+              <a:t>Data becomes far more useful when it is connected, but the capabilities needed to achieve this are limited, under-incentivised, and often hindered by entities’ reluctance to collaborate.</a:t>
+            </a:r>
+          </a:p>
+        </p:txBody>
+      </p:sp>
+    </p:spTree>
+  </p:cSld>
+</p:sld>
+</file>
+
+<file path=ppt/slides/slide11.xml><?xml version="1.0" encoding="utf-8"?>
+<p:sld xmlns:a="http://schemas.openxmlformats.org/drawingml/2006/main" xmlns:r="http://schemas.openxmlformats.org/officeDocument/2006/relationships" xmlns:p="http://schemas.openxmlformats.org/presentationml/2006/main">
+  <p:cSld>
+    <p:spTree>
+      <p:nvGrpSpPr>
+        <p:cNvPr id="1" name=""/>
+        <p:cNvGrpSpPr/>
+        <p:nvPr/>
+      </p:nvGrpSpPr>
+      <p:grpSpPr>
+        <a:xfrm>
+          <a:off x="0" y="0"/>
+          <a:ext cx="0" cy="0"/>
+          <a:chOff x="0" y="0"/>
+          <a:chExt cx="0" cy="0"/>
+        </a:xfrm>
+      </p:grpSpPr>
+      <p:sp>
+        <p:nvSpPr>
+          <p:cNvPr id="2" name="Title 1"/>
+          <p:cNvSpPr>
+            <a:spLocks noGrp="1"/>
+          </p:cNvSpPr>
+          <p:nvPr>
+            <p:ph type="title"/>
+          </p:nvPr>
+        </p:nvSpPr>
+        <p:spPr/>
+        <p:txBody>
+          <a:bodyPr/>
+          <a:lstStyle/>
+          <a:p>
+            <a:pPr lvl="0" indent="0" marL="0">
+              <a:buNone/>
+            </a:pPr>
+            <a:r>
+              <a:rPr/>
+              <a:t>Multiple public portals</a:t>
+            </a:r>
+          </a:p>
+        </p:txBody>
+      </p:sp>
+      <p:pic>
+        <p:nvPicPr>
+          <p:cNvPr descr="../images/un80_multiple_portals.png" id="0" name="Picture 1"/>
+          <p:cNvPicPr>
+            <a:picLocks noGrp="1" noChangeAspect="1"/>
+          </p:cNvPicPr>
+          <p:nvPr/>
+        </p:nvPicPr>
+        <p:blipFill>
+          <a:blip r:embed="rId2"/>
+          <a:stretch>
+            <a:fillRect/>
+          </a:stretch>
+        </p:blipFill>
+        <p:spPr bwMode="auto">
+          <a:xfrm>
+            <a:off x="2857500" y="1193800"/>
+            <a:ext cx="3429000" cy="3390900"/>
+          </a:xfrm>
+          <a:prstGeom prst="rect">
+            <a:avLst/>
+          </a:prstGeom>
+          <a:noFill/>
+          <a:ln w="9525">
+            <a:noFill/>
+            <a:headEnd/>
+            <a:tailEnd/>
+          </a:ln>
+        </p:spPr>
+      </p:pic>
+    </p:spTree>
+  </p:cSld>
+</p:sld>
+</file>
+
+<file path=ppt/slides/slide12.xml><?xml version="1.0" encoding="utf-8"?>
+<p:sld xmlns:a="http://schemas.openxmlformats.org/drawingml/2006/main" xmlns:r="http://schemas.openxmlformats.org/officeDocument/2006/relationships" xmlns:p="http://schemas.openxmlformats.org/presentationml/2006/main">
+  <p:cSld>
+    <p:spTree>
+      <p:nvGrpSpPr>
+        <p:cNvPr id="1" name=""/>
+        <p:cNvGrpSpPr/>
+        <p:nvPr/>
+      </p:nvGrpSpPr>
+      <p:grpSpPr>
+        <a:xfrm>
+          <a:off x="0" y="0"/>
+          <a:ext cx="0" cy="0"/>
+          <a:chOff x="0" y="0"/>
+          <a:chExt cx="0" cy="0"/>
+        </a:xfrm>
+      </p:grpSpPr>
+      <p:sp>
+        <p:nvSpPr>
+          <p:cNvPr id="2" name="Title 1"/>
+          <p:cNvSpPr>
+            <a:spLocks noGrp="1"/>
+          </p:cNvSpPr>
+          <p:nvPr>
+            <p:ph type="title"/>
+          </p:nvPr>
+        </p:nvSpPr>
+        <p:spPr/>
+        <p:txBody>
+          <a:bodyPr/>
+          <a:lstStyle/>
+          <a:p>
+            <a:pPr lvl="0" indent="0" marL="0">
+              <a:buNone/>
+            </a:pPr>
+            <a:r>
+              <a:rPr/>
               <a:t>The solution</a:t>
             </a:r>
           </a:p>
@@ -3251,6 +3408,69 @@
               <a:t>Entities will retain only the data that must remain separate, while all shareable data will be openly shared.</a:t>
             </a:r>
           </a:p>
+        </p:txBody>
+      </p:sp>
+    </p:spTree>
+  </p:cSld>
+</p:sld>
+</file>
+
+<file path=ppt/slides/slide13.xml><?xml version="1.0" encoding="utf-8"?>
+<p:sld xmlns:a="http://schemas.openxmlformats.org/drawingml/2006/main" xmlns:r="http://schemas.openxmlformats.org/officeDocument/2006/relationships" xmlns:p="http://schemas.openxmlformats.org/presentationml/2006/main">
+  <p:cSld>
+    <p:spTree>
+      <p:nvGrpSpPr>
+        <p:cNvPr id="1" name=""/>
+        <p:cNvGrpSpPr/>
+        <p:nvPr/>
+      </p:nvGrpSpPr>
+      <p:grpSpPr>
+        <a:xfrm>
+          <a:off x="0" y="0"/>
+          <a:ext cx="0" cy="0"/>
+          <a:chOff x="0" y="0"/>
+          <a:chExt cx="0" cy="0"/>
+        </a:xfrm>
+      </p:grpSpPr>
+      <p:sp>
+        <p:nvSpPr>
+          <p:cNvPr id="2" name="Title 1"/>
+          <p:cNvSpPr>
+            <a:spLocks noGrp="1"/>
+          </p:cNvSpPr>
+          <p:nvPr>
+            <p:ph type="title"/>
+          </p:nvPr>
+        </p:nvSpPr>
+        <p:spPr/>
+        <p:txBody>
+          <a:bodyPr/>
+          <a:lstStyle/>
+          <a:p>
+            <a:pPr lvl="0" indent="0" marL="0">
+              <a:buNone/>
+            </a:pPr>
+            <a:r>
+              <a:rPr/>
+              <a:t>The solution (continued)</a:t>
+            </a:r>
+          </a:p>
+        </p:txBody>
+      </p:sp>
+      <p:sp>
+        <p:nvSpPr>
+          <p:cNvPr id="3" name="Content Placeholder 2"/>
+          <p:cNvSpPr>
+            <a:spLocks noGrp="1"/>
+          </p:cNvSpPr>
+          <p:nvPr>
+            <p:ph idx="1"/>
+          </p:nvPr>
+        </p:nvSpPr>
+        <p:spPr/>
+        <p:txBody>
+          <a:bodyPr/>
+          <a:lstStyle/>
           <a:p>
             <a:pPr lvl="0"/>
             <a:r>
@@ -3456,27 +3676,6 @@
               <a:t> is spent each year on software, cloud services, connectivity, and related support.</a:t>
             </a:r>
           </a:p>
-          <a:p>
-            <a:pPr lvl="0"/>
-            <a:r>
-              <a:rPr/>
-              <a:t>Much of this spending happens in isolation, without scale, leading to higher costs, duplication, and weak interoperability.</a:t>
-            </a:r>
-          </a:p>
-          <a:p>
-            <a:pPr lvl="0"/>
-            <a:r>
-              <a:rPr/>
-              <a:t>These inefficiencies slow the UN’s ability to modernise and build future-ready capabilities.</a:t>
-            </a:r>
-          </a:p>
-          <a:p>
-            <a:pPr lvl="0"/>
-            <a:r>
-              <a:rPr/>
-              <a:t>To remain credible and effective, the UN system must accelerate its digital adaptation.</a:t>
-            </a:r>
-          </a:p>
         </p:txBody>
       </p:sp>
     </p:spTree>
@@ -3485,6 +3684,90 @@
 </file>
 
 <file path=ppt/slides/slide5.xml><?xml version="1.0" encoding="utf-8"?>
+<p:sld xmlns:a="http://schemas.openxmlformats.org/drawingml/2006/main" xmlns:r="http://schemas.openxmlformats.org/officeDocument/2006/relationships" xmlns:p="http://schemas.openxmlformats.org/presentationml/2006/main">
+  <p:cSld>
+    <p:spTree>
+      <p:nvGrpSpPr>
+        <p:cNvPr id="1" name=""/>
+        <p:cNvGrpSpPr/>
+        <p:nvPr/>
+      </p:nvGrpSpPr>
+      <p:grpSpPr>
+        <a:xfrm>
+          <a:off x="0" y="0"/>
+          <a:ext cx="0" cy="0"/>
+          <a:chOff x="0" y="0"/>
+          <a:chExt cx="0" cy="0"/>
+        </a:xfrm>
+      </p:grpSpPr>
+      <p:sp>
+        <p:nvSpPr>
+          <p:cNvPr id="2" name="Title 1"/>
+          <p:cNvSpPr>
+            <a:spLocks noGrp="1"/>
+          </p:cNvSpPr>
+          <p:nvPr>
+            <p:ph type="title"/>
+          </p:nvPr>
+        </p:nvSpPr>
+        <p:spPr/>
+        <p:txBody>
+          <a:bodyPr/>
+          <a:lstStyle/>
+          <a:p>
+            <a:pPr lvl="0" indent="0" marL="0">
+              <a:buNone/>
+            </a:pPr>
+            <a:r>
+              <a:rPr/>
+              <a:t>The problem (continued)</a:t>
+            </a:r>
+          </a:p>
+        </p:txBody>
+      </p:sp>
+      <p:sp>
+        <p:nvSpPr>
+          <p:cNvPr id="3" name="Content Placeholder 2"/>
+          <p:cNvSpPr>
+            <a:spLocks noGrp="1"/>
+          </p:cNvSpPr>
+          <p:nvPr>
+            <p:ph idx="1"/>
+          </p:nvPr>
+        </p:nvSpPr>
+        <p:spPr/>
+        <p:txBody>
+          <a:bodyPr/>
+          <a:lstStyle/>
+          <a:p>
+            <a:pPr lvl="0"/>
+            <a:r>
+              <a:rPr/>
+              <a:t>Much of this spending happens in isolation, without scale, leading to higher costs, duplication, and weak interoperability.</a:t>
+            </a:r>
+          </a:p>
+          <a:p>
+            <a:pPr lvl="0"/>
+            <a:r>
+              <a:rPr/>
+              <a:t>These inefficiencies slow the UN’s ability to modernise and build future-ready capabilities.</a:t>
+            </a:r>
+          </a:p>
+          <a:p>
+            <a:pPr lvl="0"/>
+            <a:r>
+              <a:rPr/>
+              <a:t>To remain credible and effective, the UN system must accelerate its digital adaptation.</a:t>
+            </a:r>
+          </a:p>
+        </p:txBody>
+      </p:sp>
+    </p:spTree>
+  </p:cSld>
+</p:sld>
+</file>
+
+<file path=ppt/slides/slide6.xml><?xml version="1.0" encoding="utf-8"?>
 <p:sld xmlns:a="http://schemas.openxmlformats.org/drawingml/2006/main" xmlns:r="http://schemas.openxmlformats.org/officeDocument/2006/relationships" xmlns:p="http://schemas.openxmlformats.org/presentationml/2006/main">
   <p:cSld>
     <p:spTree>
@@ -3561,112 +3844,6 @@
 </p:sld>
 </file>
 
-<file path=ppt/slides/slide6.xml><?xml version="1.0" encoding="utf-8"?>
-<p:sld xmlns:a="http://schemas.openxmlformats.org/drawingml/2006/main" xmlns:r="http://schemas.openxmlformats.org/officeDocument/2006/relationships" xmlns:p="http://schemas.openxmlformats.org/presentationml/2006/main">
-  <p:cSld>
-    <p:spTree>
-      <p:nvGrpSpPr>
-        <p:cNvPr id="1" name=""/>
-        <p:cNvGrpSpPr/>
-        <p:nvPr/>
-      </p:nvGrpSpPr>
-      <p:grpSpPr>
-        <a:xfrm>
-          <a:off x="0" y="0"/>
-          <a:ext cx="0" cy="0"/>
-          <a:chOff x="0" y="0"/>
-          <a:chExt cx="0" cy="0"/>
-        </a:xfrm>
-      </p:grpSpPr>
-      <p:sp>
-        <p:nvSpPr>
-          <p:cNvPr id="2" name="Title 1"/>
-          <p:cNvSpPr>
-            <a:spLocks noGrp="1"/>
-          </p:cNvSpPr>
-          <p:nvPr>
-            <p:ph type="title"/>
-          </p:nvPr>
-        </p:nvSpPr>
-        <p:spPr/>
-        <p:txBody>
-          <a:bodyPr/>
-          <a:lstStyle/>
-          <a:p>
-            <a:pPr lvl="0" indent="0" marL="0">
-              <a:buNone/>
-            </a:pPr>
-            <a:r>
-              <a:rPr/>
-              <a:t>The solution</a:t>
-            </a:r>
-          </a:p>
-        </p:txBody>
-      </p:sp>
-      <p:sp>
-        <p:nvSpPr>
-          <p:cNvPr id="3" name="Content Placeholder 2"/>
-          <p:cNvSpPr>
-            <a:spLocks noGrp="1"/>
-          </p:cNvSpPr>
-          <p:nvPr>
-            <p:ph idx="1"/>
-          </p:nvPr>
-        </p:nvSpPr>
-        <p:spPr/>
-        <p:txBody>
-          <a:bodyPr/>
-          <a:lstStyle/>
-          <a:p>
-            <a:pPr lvl="0"/>
-            <a:r>
-              <a:rPr/>
-              <a:t>The UN aims to harness technology responsibly to transform all aspects of its work.</a:t>
-            </a:r>
-          </a:p>
-          <a:p>
-            <a:pPr lvl="0"/>
-            <a:r>
-              <a:rPr/>
-              <a:t>Shared ICT services and the UN 2.0 Agenda will guide this transformation.</a:t>
-            </a:r>
-          </a:p>
-          <a:p>
-            <a:pPr lvl="0"/>
-            <a:r>
-              <a:rPr/>
-              <a:t>A new </a:t>
-            </a:r>
-            <a:r>
-              <a:rPr b="1"/>
-              <a:t>Technology Accelerator Platform</a:t>
-            </a:r>
-            <a:r>
-              <a:rPr/>
-              <a:t> will act as the system’s engine for change.</a:t>
-            </a:r>
-          </a:p>
-          <a:p>
-            <a:pPr lvl="0"/>
-            <a:r>
-              <a:rPr/>
-              <a:t>It will modernise internal UN operations.</a:t>
-            </a:r>
-          </a:p>
-          <a:p>
-            <a:pPr lvl="0"/>
-            <a:r>
-              <a:rPr/>
-              <a:t>It will also enhance the UN’s ability to support Member States in adopting digital and AI solutions effectively and responsibly.</a:t>
-            </a:r>
-          </a:p>
-        </p:txBody>
-      </p:sp>
-    </p:spTree>
-  </p:cSld>
-</p:sld>
-</file>
-
 <file path=ppt/slides/slide7.xml><?xml version="1.0" encoding="utf-8"?>
 <p:sld xmlns:a="http://schemas.openxmlformats.org/drawingml/2006/main" xmlns:r="http://schemas.openxmlformats.org/officeDocument/2006/relationships" xmlns:p="http://schemas.openxmlformats.org/presentationml/2006/main">
   <p:cSld>
@@ -3704,7 +3881,66 @@
             </a:pPr>
             <a:r>
               <a:rPr/>
-              <a:t>Fragmented data, missed opportunities</a:t>
+              <a:t>The solution</a:t>
+            </a:r>
+          </a:p>
+        </p:txBody>
+      </p:sp>
+      <p:sp>
+        <p:nvSpPr>
+          <p:cNvPr id="3" name="Content Placeholder 2"/>
+          <p:cNvSpPr>
+            <a:spLocks noGrp="1"/>
+          </p:cNvSpPr>
+          <p:nvPr>
+            <p:ph idx="1"/>
+          </p:nvPr>
+        </p:nvSpPr>
+        <p:spPr/>
+        <p:txBody>
+          <a:bodyPr/>
+          <a:lstStyle/>
+          <a:p>
+            <a:pPr lvl="0"/>
+            <a:r>
+              <a:rPr/>
+              <a:t>The UN aims to harness technology responsibly to transform all aspects of its work.</a:t>
+            </a:r>
+          </a:p>
+          <a:p>
+            <a:pPr lvl="0"/>
+            <a:r>
+              <a:rPr/>
+              <a:t>Shared ICT services and the UN 2.0 Agenda will guide this transformation.</a:t>
+            </a:r>
+          </a:p>
+          <a:p>
+            <a:pPr lvl="0"/>
+            <a:r>
+              <a:rPr/>
+              <a:t>A new </a:t>
+            </a:r>
+            <a:r>
+              <a:rPr b="1"/>
+              <a:t>Technology Accelerator Platform</a:t>
+            </a:r>
+            <a:r>
+              <a:rPr/>
+              <a:t> will act as the system’s engine for change.</a:t>
+            </a:r>
+          </a:p>
+          <a:p>
+            <a:pPr lvl="0"/>
+            <a:r>
+              <a:rPr/>
+              <a:t>It will modernise internal UN operations.</a:t>
+            </a:r>
+          </a:p>
+          <a:p>
+            <a:pPr lvl="0"/>
+            <a:r>
+              <a:rPr/>
+              <a:t>It will also enhance the UN’s ability to support Member States in adopting digital and AI solutions effectively and responsibly.</a:t>
             </a:r>
           </a:p>
         </p:txBody>
@@ -3751,58 +3987,7 @@
             </a:pPr>
             <a:r>
               <a:rPr/>
-              <a:t>The problem</a:t>
-            </a:r>
-          </a:p>
-        </p:txBody>
-      </p:sp>
-      <p:sp>
-        <p:nvSpPr>
-          <p:cNvPr id="3" name="Content Placeholder 2"/>
-          <p:cNvSpPr>
-            <a:spLocks noGrp="1"/>
-          </p:cNvSpPr>
-          <p:nvPr>
-            <p:ph idx="1"/>
-          </p:nvPr>
-        </p:nvSpPr>
-        <p:spPr/>
-        <p:txBody>
-          <a:bodyPr/>
-          <a:lstStyle/>
-          <a:p>
-            <a:pPr lvl="0"/>
-            <a:r>
-              <a:rPr/>
-              <a:t>The UN system serves as a major custodian of global public data, statistics, and insights on topics ranging from population trends to climate risks.</a:t>
-            </a:r>
-          </a:p>
-          <a:p>
-            <a:pPr lvl="0"/>
-            <a:r>
-              <a:rPr/>
-              <a:t>Despite this, its data platforms remain fragmented and duplicative, even as demand for faster and clearer information grows.</a:t>
-            </a:r>
-          </a:p>
-          <a:p>
-            <a:pPr lvl="0"/>
-            <a:r>
-              <a:rPr/>
-              <a:t>Individual UN entities have built separate systems, resulting in parallel capacities that rarely connect.</a:t>
-            </a:r>
-          </a:p>
-          <a:p>
-            <a:pPr lvl="0"/>
-            <a:r>
-              <a:rPr/>
-              <a:t>Without interoperability, data cannot be shared effectively across entities, leading to blind spots, wasted effort, and missed opportunities to address interconnected global challenges.</a:t>
-            </a:r>
-          </a:p>
-          <a:p>
-            <a:pPr lvl="0"/>
-            <a:r>
-              <a:rPr/>
-              <a:t>Data becomes far more useful when it is connected, but the capabilities needed to achieve this are limited, under-incentivised, and often hindered by entities’ reluctance to collaborate.</a:t>
+              <a:t>Fragmented data, missed opportunities</a:t>
             </a:r>
           </a:p>
         </p:txBody>
@@ -3849,41 +4034,48 @@
             </a:pPr>
             <a:r>
               <a:rPr/>
-              <a:t>Multiple public portals</a:t>
-            </a:r>
-          </a:p>
-        </p:txBody>
-      </p:sp>
-      <p:pic>
-        <p:nvPicPr>
-          <p:cNvPr descr="../images/un80_multiple_portals.png" id="0" name="Picture 1"/>
-          <p:cNvPicPr>
-            <a:picLocks noGrp="1" noChangeAspect="1"/>
-          </p:cNvPicPr>
-          <p:nvPr/>
-        </p:nvPicPr>
-        <p:blipFill>
-          <a:blip r:embed="rId2"/>
-          <a:stretch>
-            <a:fillRect/>
-          </a:stretch>
-        </p:blipFill>
-        <p:spPr bwMode="auto">
-          <a:xfrm>
-            <a:off x="2857500" y="1193800"/>
-            <a:ext cx="3429000" cy="3390900"/>
-          </a:xfrm>
-          <a:prstGeom prst="rect">
-            <a:avLst/>
-          </a:prstGeom>
-          <a:noFill/>
-          <a:ln w="9525">
-            <a:noFill/>
-            <a:headEnd/>
-            <a:tailEnd/>
-          </a:ln>
-        </p:spPr>
-      </p:pic>
+              <a:t>The problem</a:t>
+            </a:r>
+          </a:p>
+        </p:txBody>
+      </p:sp>
+      <p:sp>
+        <p:nvSpPr>
+          <p:cNvPr id="3" name="Content Placeholder 2"/>
+          <p:cNvSpPr>
+            <a:spLocks noGrp="1"/>
+          </p:cNvSpPr>
+          <p:nvPr>
+            <p:ph idx="1"/>
+          </p:nvPr>
+        </p:nvSpPr>
+        <p:spPr/>
+        <p:txBody>
+          <a:bodyPr/>
+          <a:lstStyle/>
+          <a:p>
+            <a:pPr lvl="0"/>
+            <a:r>
+              <a:rPr/>
+              <a:t>The UN system serves as a major custodian of global public data, statistics, and insights on topics ranging from population trends to climate risks.</a:t>
+            </a:r>
+          </a:p>
+          <a:p>
+            <a:pPr lvl="0"/>
+            <a:r>
+              <a:rPr/>
+              <a:t>Despite this, its data platforms remain fragmented and duplicative, even as demand for faster and clearer information grows.</a:t>
+            </a:r>
+          </a:p>
+          <a:p>
+            <a:pPr lvl="0"/>
+            <a:r>
+              <a:rPr/>
+              <a:t>Individual UN entities have built separate systems, resulting in parallel capacities that rarely connect.</a:t>
+            </a:r>
+          </a:p>
+        </p:txBody>
+      </p:sp>
     </p:spTree>
   </p:cSld>
 </p:sld>

</xml_diff>